<commit_message>
Update UNIDAD 5 - cambios en archivos Act 5.1 y Act 5.2
</commit_message>
<xml_diff>
--- a/UNIDAD 5/Act_5.2_LYA1_Reporte_de_Practica_Amaury-Gordillo.pptx
+++ b/UNIDAD 5/Act_5.2_LYA1_Reporte_de_Practica_Amaury-Gordillo.pptx
@@ -6614,6 +6614,30 @@
               </a:rPr>
               <a:t>Reporte</a:t>
             </a:r>
+            <a:r>
+              <a:rPr lang="en-US" sz="2625" b="1" dirty="0">
+                <a:solidFill>
+                  <a:srgbClr val="000000"/>
+                </a:solidFill>
+                <a:latin typeface="Montserrat Bold"/>
+                <a:ea typeface="Montserrat Bold"/>
+                <a:cs typeface="Montserrat Bold"/>
+                <a:sym typeface="Montserrat Bold"/>
+              </a:rPr>
+              <a:t> De </a:t>
+            </a:r>
+            <a:r>
+              <a:rPr lang="en-US" sz="2625" b="1" dirty="0" err="1">
+                <a:solidFill>
+                  <a:srgbClr val="000000"/>
+                </a:solidFill>
+                <a:latin typeface="Montserrat Bold"/>
+                <a:ea typeface="Montserrat Bold"/>
+                <a:cs typeface="Montserrat Bold"/>
+                <a:sym typeface="Montserrat Bold"/>
+              </a:rPr>
+              <a:t>Practica</a:t>
+            </a:r>
             <a:endParaRPr lang="en-US" sz="2625" b="1" dirty="0">
               <a:solidFill>
                 <a:srgbClr val="000000"/>
@@ -7821,7 +7845,7 @@
         <p:spPr>
           <a:xfrm>
             <a:off x="619704" y="1181100"/>
-            <a:ext cx="17439696" cy="954107"/>
+            <a:ext cx="17439696" cy="830997"/>
           </a:xfrm>
           <a:prstGeom prst="rect">
             <a:avLst/>
@@ -7835,15 +7859,15 @@
           <a:lstStyle/>
           <a:p>
             <a:r>
-              <a:rPr lang="es-MX" sz="2800" dirty="0">
+              <a:rPr lang="es-MX" sz="2400" dirty="0">
                 <a:hlinkClick r:id="rId3"/>
               </a:rPr>
-              <a:t>https://github.com/amaurycolochos-cpu/LENGUAJES-Y-AUTOMATAS-1/tree/main/UNIDAD%204/AnalizadorLexicoFX</a:t>
-            </a:r>
-            <a:endParaRPr lang="es-MX" sz="2800" dirty="0"/>
-          </a:p>
-          <a:p>
-            <a:endParaRPr lang="es-MX" sz="2800" dirty="0"/>
+              <a:t>https://github.com/amaurycolochos-cpu/LENGUAJES-Y-AUTOMATAS-1/tree/main/UNIDAD%205/Reporte%20Act%205.2</a:t>
+            </a:r>
+            <a:endParaRPr lang="es-MX" sz="2400" dirty="0"/>
+          </a:p>
+          <a:p>
+            <a:endParaRPr lang="es-MX" sz="2400" dirty="0"/>
           </a:p>
         </p:txBody>
       </p:sp>

</xml_diff>